<commit_message>
Keep the course executable against current agent SDK contracts
Align Korean and English teaching sources with verified LangChain, LangGraph,
Deep Agents and LangSmith contracts, then regenerate both handbooks and all
five lecture deck sets from preserved editable source. Record the research,
validation boundaries and v1.3.0 release guidance alongside the materials.

Constraint: Preserve the existing curriculum and source model policy
Rejected: Rewrite all upstream documentation | unrelated provider churn would obscure contract corrections
Confidence: high
Scope-risk: broad
Directive: Update notebook and derived book/deck sources together when SDK contracts change
Tested: 241 notebook/static contract checks; 16 offline tests; 10 deterministic nbclient executions; Ruff; Pyright; uv lock; Typst builds; deck package and visual checks
Not-tested: Full external-provider and cloud-sandbox execution; changed-only GPT-6 Luna batch canceled by user
</commit_message>
<xml_diff>
--- a/decks/01_beginner/01_beginner.pptx
+++ b/decks/01_beginner/01_beginner.pptx
@@ -2011,7 +2011,7 @@
           <a:lstStyle/>
           <a:p>
             <a:r>
-              <a:t>직접 그리는 것도 좋지만, 복잡한 일은 다 차려진 밥상이 편하죠. Deep Agents입니다.</a:t>
+              <a:t>직접 그리는 것도 좋지만, 파일 작업과 서브에이전트가 필요한 장기 작업에는 Deep Agents 하네스가 편합니다. 계획이 필요한 작업에서는 TodoListMiddleware를 명시적으로 붙입니다.</a:t>
             </a:r>
           </a:p>
         </p:txBody>
@@ -2081,7 +2081,7 @@
           <a:lstStyle/>
           <a:p>
             <a:r>
-              <a:t>헷갈리기 쉬운데, 셋은 경쟁 관계가 아닙니다. 맨 아래 LangChain이 모델과 도구를 잇는 토대이고, 그 위에 LangGraph가 흐름 제어를 얹고, 맨 위 Deep Agents가 계획·파일까지 내장한 올인원입니다. 위로 갈수록 더 많은 게 들어있고, 각 층은 아래 층을 그대로 씁니다.</a:t>
+              <a:t>헷갈리기 쉬운데, 셋은 경쟁 관계가 아닙니다. 맨 아래 LangChain이 모델과 도구를 잇는 토대이고, 그 위에 LangGraph가 흐름 제어를 얹습니다. Deep Agents는 그 위에 파일, 서브에이전트, 백엔드가 붙은 장기 작업 하네스입니다. 계획 도구는 이제 기본이라고 외우기보다, 필요한 작업에서 TodoListMiddleware로 붙인다고 기억하면 됩니다.</a:t>
             </a:r>
           </a:p>
         </p:txBody>
@@ -2151,7 +2151,7 @@
           <a:lstStyle/>
           <a:p>
             <a:r>
-              <a:t>create_deep_agent는 모델만 넘겨도 다섯 가지가 딸려옵니다. 계획을 세우는 투두, 중간 결과를 파일에 저장하는 컨텍스트 관리, 교체 가능한 백엔드, 일을 맡기는 서브에이전트, 그리고 영구 메모리예요. 이걸 통틀어 하네스라고 부릅니다.</a:t>
+              <a:t>Deep Agents는 하네스 자체와 선택 미들웨어를 구분해서 봐야 합니다. 파일 작업, 백엔드, 서브에이전트는 장기 작업의 중심 표면이고, 단계 계획은 TodoListMiddleware를 붙였을 때 활성화됩니다. 그래서 최신 버전에서는 모델만 넘기면 계획까지 항상 켜진다고 설명하지 않습니다.</a:t>
             </a:r>
           </a:p>
         </p:txBody>
@@ -2221,7 +2221,7 @@
           <a:lstStyle/>
           <a:p>
             <a:r>
-              <a:t>여기서 LangChain이랑 다른 점이 하나 있어요. Deep Agents는 도구를 줄 때 @tool을 안 붙여도 됩니다. 그냥 설명문과 타입 힌트가 달린 순수 함수를 그대로 넘기면 돼요. ▶ greet 도구를 단 에이전트를 돌려보면, 계획·파일 도구가 이미 안에 들어있는 걸 볼 수 있습니다.</a:t>
+              <a:t>도구를 순수 함수로 넘기는 패턴은 유지됩니다. 달라진 포인트는 계획입니다. 리서치나 보고서처럼 여러 단계를 추적해야 할 때 TodoListMiddleware를 middleware 목록에 명시합니다. 이 한 줄이 있어야 todo 상태를 수업에서 다룰 수 있습니다.</a:t>
             </a:r>
           </a:p>
         </p:txBody>
@@ -2711,7 +2711,7 @@
           <a:lstStyle/>
           <a:p>
             <a:r>
-              <a:t>이제 이 검색 도구와 시스템 프롬프트만 create_deep_agent에 넘기면 끝이에요. 계획 세우고, 검색하고, 중간 노트 쓰고, 종합하는 건 내장 기능이 알아서 합니다. ▶ 'LangChain v1 변경사항 요약해줘' 하고 스트리밍으로 돌리면, 도구 호출부터 요약까지 전 과정이 보입니다.</a:t>
+              <a:t>검색 도구와 시스템 프롬프트만으로도 에이전트는 만들 수 있습니다. 다만 긴 리서치처럼 단계 관리가 필요하면 TodoListMiddleware를 함께 붙여야 합니다. 이렇게 하면 검색, 중간 메모, 종합 단계를 todo로 관찰하면서 설명할 수 있습니다.</a:t>
             </a:r>
           </a:p>
         </p:txBody>
@@ -2781,7 +2781,7 @@
           <a:lstStyle/>
           <a:p>
             <a:r>
-              <a:t>같은 걸 LangChain으로도 만들어 비교해 보면 성격 차이가 분명해져요. Deep Agents는 계획·파일이 공짜로 들어있고, LangChain은 기본 ReAct라 그런 게 필요하면 직접 붙여야 합니다. 입문은 여기까지고, 다음 중급에서는 미들웨어·MCP·HITL·RAG로 더 깊이 들어갑니다.</a:t>
+              <a:t>같은 걸 LangChain으로도 만들어 비교해 보면 성격 차이가 분명해져요. LangChain은 바로 검색하고 요약하는 데 가볍고, Deep Agents는 파일 작업과 서브에이전트가 필요한 장기 작업에 맞습니다. todo 계획은 Deep Agents 0.7 기준으로 명시한 미들웨어가 담당합니다.</a:t>
             </a:r>
           </a:p>
         </p:txBody>
@@ -6279,7 +6279,7 @@
       <p:grpSpPr/>
       <p:pic>
         <p:nvPicPr>
-          <p:cNvPr id="2" name="Picture 1" descr="hp-01.png"/>
+          <p:cNvPr id="2" name="Picture 1" descr="hp-001.png"/>
           <p:cNvPicPr>
             <a:picLocks noChangeAspect="1"/>
           </p:cNvPicPr>
@@ -6321,7 +6321,7 @@
       <p:grpSpPr/>
       <p:pic>
         <p:nvPicPr>
-          <p:cNvPr id="2" name="Picture 1" descr="hp-10.png"/>
+          <p:cNvPr id="2" name="Picture 1" descr="hp-010.png"/>
           <p:cNvPicPr>
             <a:picLocks noChangeAspect="1"/>
           </p:cNvPicPr>
@@ -6363,7 +6363,7 @@
       <p:grpSpPr/>
       <p:pic>
         <p:nvPicPr>
-          <p:cNvPr id="2" name="Picture 1" descr="hp-11.png"/>
+          <p:cNvPr id="2" name="Picture 1" descr="hp-011.png"/>
           <p:cNvPicPr>
             <a:picLocks noChangeAspect="1"/>
           </p:cNvPicPr>
@@ -6405,7 +6405,7 @@
       <p:grpSpPr/>
       <p:pic>
         <p:nvPicPr>
-          <p:cNvPr id="2" name="Picture 1" descr="hp-12.png"/>
+          <p:cNvPr id="2" name="Picture 1" descr="hp-012.png"/>
           <p:cNvPicPr>
             <a:picLocks noChangeAspect="1"/>
           </p:cNvPicPr>
@@ -6447,7 +6447,7 @@
       <p:grpSpPr/>
       <p:pic>
         <p:nvPicPr>
-          <p:cNvPr id="2" name="Picture 1" descr="hp-13.png"/>
+          <p:cNvPr id="2" name="Picture 1" descr="hp-013.png"/>
           <p:cNvPicPr>
             <a:picLocks noChangeAspect="1"/>
           </p:cNvPicPr>
@@ -6489,7 +6489,7 @@
       <p:grpSpPr/>
       <p:pic>
         <p:nvPicPr>
-          <p:cNvPr id="2" name="Picture 1" descr="hp-14.png"/>
+          <p:cNvPr id="2" name="Picture 1" descr="hp-014.png"/>
           <p:cNvPicPr>
             <a:picLocks noChangeAspect="1"/>
           </p:cNvPicPr>
@@ -6531,7 +6531,7 @@
       <p:grpSpPr/>
       <p:pic>
         <p:nvPicPr>
-          <p:cNvPr id="2" name="Picture 1" descr="hp-15.png"/>
+          <p:cNvPr id="2" name="Picture 1" descr="hp-015.png"/>
           <p:cNvPicPr>
             <a:picLocks noChangeAspect="1"/>
           </p:cNvPicPr>
@@ -6573,7 +6573,7 @@
       <p:grpSpPr/>
       <p:pic>
         <p:nvPicPr>
-          <p:cNvPr id="2" name="Picture 1" descr="hp-16.png"/>
+          <p:cNvPr id="2" name="Picture 1" descr="hp-016.png"/>
           <p:cNvPicPr>
             <a:picLocks noChangeAspect="1"/>
           </p:cNvPicPr>
@@ -6615,7 +6615,7 @@
       <p:grpSpPr/>
       <p:pic>
         <p:nvPicPr>
-          <p:cNvPr id="2" name="Picture 1" descr="hp-17.png"/>
+          <p:cNvPr id="2" name="Picture 1" descr="hp-017.png"/>
           <p:cNvPicPr>
             <a:picLocks noChangeAspect="1"/>
           </p:cNvPicPr>
@@ -6657,7 +6657,7 @@
       <p:grpSpPr/>
       <p:pic>
         <p:nvPicPr>
-          <p:cNvPr id="2" name="Picture 1" descr="hp-18.png"/>
+          <p:cNvPr id="2" name="Picture 1" descr="hp-018.png"/>
           <p:cNvPicPr>
             <a:picLocks noChangeAspect="1"/>
           </p:cNvPicPr>
@@ -6699,7 +6699,7 @@
       <p:grpSpPr/>
       <p:pic>
         <p:nvPicPr>
-          <p:cNvPr id="2" name="Picture 1" descr="hp-19.png"/>
+          <p:cNvPr id="2" name="Picture 1" descr="hp-019.png"/>
           <p:cNvPicPr>
             <a:picLocks noChangeAspect="1"/>
           </p:cNvPicPr>
@@ -6741,7 +6741,7 @@
       <p:grpSpPr/>
       <p:pic>
         <p:nvPicPr>
-          <p:cNvPr id="2" name="Picture 1" descr="hp-02.png"/>
+          <p:cNvPr id="2" name="Picture 1" descr="hp-002.png"/>
           <p:cNvPicPr>
             <a:picLocks noChangeAspect="1"/>
           </p:cNvPicPr>
@@ -6783,7 +6783,7 @@
       <p:grpSpPr/>
       <p:pic>
         <p:nvPicPr>
-          <p:cNvPr id="2" name="Picture 1" descr="hp-20.png"/>
+          <p:cNvPr id="2" name="Picture 1" descr="hp-020.png"/>
           <p:cNvPicPr>
             <a:picLocks noChangeAspect="1"/>
           </p:cNvPicPr>
@@ -6825,7 +6825,7 @@
       <p:grpSpPr/>
       <p:pic>
         <p:nvPicPr>
-          <p:cNvPr id="2" name="Picture 1" descr="hp-21.png"/>
+          <p:cNvPr id="2" name="Picture 1" descr="hp-021.png"/>
           <p:cNvPicPr>
             <a:picLocks noChangeAspect="1"/>
           </p:cNvPicPr>
@@ -6867,7 +6867,7 @@
       <p:grpSpPr/>
       <p:pic>
         <p:nvPicPr>
-          <p:cNvPr id="2" name="Picture 1" descr="hp-22.png"/>
+          <p:cNvPr id="2" name="Picture 1" descr="hp-022.png"/>
           <p:cNvPicPr>
             <a:picLocks noChangeAspect="1"/>
           </p:cNvPicPr>
@@ -6909,7 +6909,7 @@
       <p:grpSpPr/>
       <p:pic>
         <p:nvPicPr>
-          <p:cNvPr id="2" name="Picture 1" descr="hp-23.png"/>
+          <p:cNvPr id="2" name="Picture 1" descr="hp-023.png"/>
           <p:cNvPicPr>
             <a:picLocks noChangeAspect="1"/>
           </p:cNvPicPr>
@@ -6951,7 +6951,7 @@
       <p:grpSpPr/>
       <p:pic>
         <p:nvPicPr>
-          <p:cNvPr id="2" name="Picture 1" descr="hp-24.png"/>
+          <p:cNvPr id="2" name="Picture 1" descr="hp-024.png"/>
           <p:cNvPicPr>
             <a:picLocks noChangeAspect="1"/>
           </p:cNvPicPr>
@@ -6993,7 +6993,7 @@
       <p:grpSpPr/>
       <p:pic>
         <p:nvPicPr>
-          <p:cNvPr id="2" name="Picture 1" descr="hp-25.png"/>
+          <p:cNvPr id="2" name="Picture 1" descr="hp-025.png"/>
           <p:cNvPicPr>
             <a:picLocks noChangeAspect="1"/>
           </p:cNvPicPr>
@@ -7035,7 +7035,7 @@
       <p:grpSpPr/>
       <p:pic>
         <p:nvPicPr>
-          <p:cNvPr id="2" name="Picture 1" descr="hp-26.png"/>
+          <p:cNvPr id="2" name="Picture 1" descr="hp-026.png"/>
           <p:cNvPicPr>
             <a:picLocks noChangeAspect="1"/>
           </p:cNvPicPr>
@@ -7077,7 +7077,7 @@
       <p:grpSpPr/>
       <p:pic>
         <p:nvPicPr>
-          <p:cNvPr id="2" name="Picture 1" descr="hp-27.png"/>
+          <p:cNvPr id="2" name="Picture 1" descr="hp-027.png"/>
           <p:cNvPicPr>
             <a:picLocks noChangeAspect="1"/>
           </p:cNvPicPr>
@@ -7119,7 +7119,7 @@
       <p:grpSpPr/>
       <p:pic>
         <p:nvPicPr>
-          <p:cNvPr id="2" name="Picture 1" descr="hp-28.png"/>
+          <p:cNvPr id="2" name="Picture 1" descr="hp-028.png"/>
           <p:cNvPicPr>
             <a:picLocks noChangeAspect="1"/>
           </p:cNvPicPr>
@@ -7161,7 +7161,7 @@
       <p:grpSpPr/>
       <p:pic>
         <p:nvPicPr>
-          <p:cNvPr id="2" name="Picture 1" descr="hp-29.png"/>
+          <p:cNvPr id="2" name="Picture 1" descr="hp-029.png"/>
           <p:cNvPicPr>
             <a:picLocks noChangeAspect="1"/>
           </p:cNvPicPr>
@@ -7203,7 +7203,7 @@
       <p:grpSpPr/>
       <p:pic>
         <p:nvPicPr>
-          <p:cNvPr id="2" name="Picture 1" descr="hp-03.png"/>
+          <p:cNvPr id="2" name="Picture 1" descr="hp-003.png"/>
           <p:cNvPicPr>
             <a:picLocks noChangeAspect="1"/>
           </p:cNvPicPr>
@@ -7245,7 +7245,7 @@
       <p:grpSpPr/>
       <p:pic>
         <p:nvPicPr>
-          <p:cNvPr id="2" name="Picture 1" descr="hp-30.png"/>
+          <p:cNvPr id="2" name="Picture 1" descr="hp-030.png"/>
           <p:cNvPicPr>
             <a:picLocks noChangeAspect="1"/>
           </p:cNvPicPr>
@@ -7287,7 +7287,7 @@
       <p:grpSpPr/>
       <p:pic>
         <p:nvPicPr>
-          <p:cNvPr id="2" name="Picture 1" descr="hp-31.png"/>
+          <p:cNvPr id="2" name="Picture 1" descr="hp-031.png"/>
           <p:cNvPicPr>
             <a:picLocks noChangeAspect="1"/>
           </p:cNvPicPr>
@@ -7329,7 +7329,7 @@
       <p:grpSpPr/>
       <p:pic>
         <p:nvPicPr>
-          <p:cNvPr id="2" name="Picture 1" descr="hp-32.png"/>
+          <p:cNvPr id="2" name="Picture 1" descr="hp-032.png"/>
           <p:cNvPicPr>
             <a:picLocks noChangeAspect="1"/>
           </p:cNvPicPr>
@@ -7371,7 +7371,7 @@
       <p:grpSpPr/>
       <p:pic>
         <p:nvPicPr>
-          <p:cNvPr id="2" name="Picture 1" descr="hp-33.png"/>
+          <p:cNvPr id="2" name="Picture 1" descr="hp-033.png"/>
           <p:cNvPicPr>
             <a:picLocks noChangeAspect="1"/>
           </p:cNvPicPr>
@@ -7413,7 +7413,7 @@
       <p:grpSpPr/>
       <p:pic>
         <p:nvPicPr>
-          <p:cNvPr id="2" name="Picture 1" descr="hp-34.png"/>
+          <p:cNvPr id="2" name="Picture 1" descr="hp-034.png"/>
           <p:cNvPicPr>
             <a:picLocks noChangeAspect="1"/>
           </p:cNvPicPr>
@@ -7455,7 +7455,7 @@
       <p:grpSpPr/>
       <p:pic>
         <p:nvPicPr>
-          <p:cNvPr id="2" name="Picture 1" descr="hp-35.png"/>
+          <p:cNvPr id="2" name="Picture 1" descr="hp-035.png"/>
           <p:cNvPicPr>
             <a:picLocks noChangeAspect="1"/>
           </p:cNvPicPr>
@@ -7497,7 +7497,7 @@
       <p:grpSpPr/>
       <p:pic>
         <p:nvPicPr>
-          <p:cNvPr id="2" name="Picture 1" descr="hp-36.png"/>
+          <p:cNvPr id="2" name="Picture 1" descr="hp-036.png"/>
           <p:cNvPicPr>
             <a:picLocks noChangeAspect="1"/>
           </p:cNvPicPr>
@@ -7539,7 +7539,7 @@
       <p:grpSpPr/>
       <p:pic>
         <p:nvPicPr>
-          <p:cNvPr id="2" name="Picture 1" descr="hp-37.png"/>
+          <p:cNvPr id="2" name="Picture 1" descr="hp-037.png"/>
           <p:cNvPicPr>
             <a:picLocks noChangeAspect="1"/>
           </p:cNvPicPr>
@@ -7581,7 +7581,7 @@
       <p:grpSpPr/>
       <p:pic>
         <p:nvPicPr>
-          <p:cNvPr id="2" name="Picture 1" descr="hp-38.png"/>
+          <p:cNvPr id="2" name="Picture 1" descr="hp-038.png"/>
           <p:cNvPicPr>
             <a:picLocks noChangeAspect="1"/>
           </p:cNvPicPr>
@@ -7623,7 +7623,7 @@
       <p:grpSpPr/>
       <p:pic>
         <p:nvPicPr>
-          <p:cNvPr id="2" name="Picture 1" descr="hp-39.png"/>
+          <p:cNvPr id="2" name="Picture 1" descr="hp-039.png"/>
           <p:cNvPicPr>
             <a:picLocks noChangeAspect="1"/>
           </p:cNvPicPr>
@@ -7665,7 +7665,7 @@
       <p:grpSpPr/>
       <p:pic>
         <p:nvPicPr>
-          <p:cNvPr id="2" name="Picture 1" descr="hp-04.png"/>
+          <p:cNvPr id="2" name="Picture 1" descr="hp-004.png"/>
           <p:cNvPicPr>
             <a:picLocks noChangeAspect="1"/>
           </p:cNvPicPr>
@@ -7707,7 +7707,7 @@
       <p:grpSpPr/>
       <p:pic>
         <p:nvPicPr>
-          <p:cNvPr id="2" name="Picture 1" descr="hp-40.png"/>
+          <p:cNvPr id="2" name="Picture 1" descr="hp-040.png"/>
           <p:cNvPicPr>
             <a:picLocks noChangeAspect="1"/>
           </p:cNvPicPr>
@@ -7749,7 +7749,7 @@
       <p:grpSpPr/>
       <p:pic>
         <p:nvPicPr>
-          <p:cNvPr id="2" name="Picture 1" descr="hp-05.png"/>
+          <p:cNvPr id="2" name="Picture 1" descr="hp-005.png"/>
           <p:cNvPicPr>
             <a:picLocks noChangeAspect="1"/>
           </p:cNvPicPr>
@@ -7791,7 +7791,7 @@
       <p:grpSpPr/>
       <p:pic>
         <p:nvPicPr>
-          <p:cNvPr id="2" name="Picture 1" descr="hp-06.png"/>
+          <p:cNvPr id="2" name="Picture 1" descr="hp-006.png"/>
           <p:cNvPicPr>
             <a:picLocks noChangeAspect="1"/>
           </p:cNvPicPr>
@@ -7833,7 +7833,7 @@
       <p:grpSpPr/>
       <p:pic>
         <p:nvPicPr>
-          <p:cNvPr id="2" name="Picture 1" descr="hp-07.png"/>
+          <p:cNvPr id="2" name="Picture 1" descr="hp-007.png"/>
           <p:cNvPicPr>
             <a:picLocks noChangeAspect="1"/>
           </p:cNvPicPr>
@@ -7875,7 +7875,7 @@
       <p:grpSpPr/>
       <p:pic>
         <p:nvPicPr>
-          <p:cNvPr id="2" name="Picture 1" descr="hp-08.png"/>
+          <p:cNvPr id="2" name="Picture 1" descr="hp-008.png"/>
           <p:cNvPicPr>
             <a:picLocks noChangeAspect="1"/>
           </p:cNvPicPr>
@@ -7917,7 +7917,7 @@
       <p:grpSpPr/>
       <p:pic>
         <p:nvPicPr>
-          <p:cNvPr id="2" name="Picture 1" descr="hp-09.png"/>
+          <p:cNvPr id="2" name="Picture 1" descr="hp-009.png"/>
           <p:cNvPicPr>
             <a:picLocks noChangeAspect="1"/>
           </p:cNvPicPr>

</xml_diff>